<commit_message>
Reorganize PPTX to match new 3-tedate classification
Slide structure changes (slides 7-10):
- Slide 7 (①関心 part 1): 1年体育 + 5-1図工 [removed 5-1外国語/三宅]
- Slide 8 (①関心 part 2): 3年算数 4学級 展開 + 「1000円札のおつり」hint
  [was slide 9 ②考え; banner changed to ①関心, 6年音楽 moved out]
- Slide 9 (②考え): 2-1算/4-2国/5-3社/6-3道
  [was slide 8; unit names updated for 4-2 and 6-3]
- Slide 10 (③行動): 2-2道/4-1社/5-2体/6-2外/6-2音 (5 items in 3+2 layout)
  [added 6-2 音楽 from old slide 9]

Unit name corrections:
- 4-2 国語: 「アップとルーズで伝える」 (was 筆者の考えを...)
- 6-3 道徳: 「自分の役割を果たす」 (was 子ども会のキャンプ)
- 2-2 道徳: 「ともだちとなかよく」 (was けんかをしたけど)

Font size adjustments:
- Slide 7 labels: 15/12pt to fit long teacher list + colorful unit name
- Slide 10 top row chips (3 items at 2.84"): 14/11pt to prevent wrap

https://claude.ai/code/session_0115j5ByNrFwaiK1mMDykaCF
</commit_message>
<xml_diff>
--- a/output/★指導課訪問★３・４校時指導助言資料（例）.pptx
+++ b/output/★指導課訪問★３・４校時指導助言資料（例）.pptx
@@ -18,8 +18,8 @@
     <p:sldId id="262" r:id="rId6"/>
     <p:sldId id="519" r:id="rId7"/>
     <p:sldId id="515" r:id="rId8"/>
+    <p:sldId id="732" r:id="rId22"/>
     <p:sldId id="526" r:id="rId9"/>
-    <p:sldId id="732" r:id="rId22"/>
     <p:sldId id="527" r:id="rId10"/>
     <p:sldId id="729" r:id="rId11"/>
     <p:sldId id="521" r:id="rId12"/>
@@ -7947,8 +7947,8 @@
         </p:nvSpPr>
         <p:spPr bwMode="white">
           <a:xfrm>
-            <a:off x="489758" y="822960"/>
-            <a:ext cx="4000000" cy="914400"/>
+            <a:off x="3273552" y="822960"/>
+            <a:ext cx="2596896" cy="1280160"/>
           </a:xfrm>
           <a:prstGeom prst="rect">
             <a:avLst/>
@@ -7968,7 +7968,7 @@
           <a:p>
             <a:pPr algn="l"/>
             <a:r>
-              <a:rPr lang="ja-JP" sz="2200" b="1" dirty="0">
+              <a:rPr lang="ja-JP" sz="1400" b="1" dirty="0">
                 <a:latin typeface="メイリオ"/>
                 <a:ea typeface="メイリオ"/>
                 <a:cs typeface="メイリオ"/>
@@ -7979,7 +7979,7 @@
           <a:p>
             <a:pPr algn="l"/>
             <a:r>
-              <a:rPr lang="ja-JP" sz="1600" b="0" dirty="0">
+              <a:rPr lang="ja-JP" sz="1100" b="0" dirty="0">
                 <a:latin typeface="メイリオ"/>
                 <a:ea typeface="メイリオ"/>
                 <a:cs typeface="メイリオ"/>
@@ -8003,8 +8003,8 @@
         </p:nvSpPr>
         <p:spPr bwMode="white">
           <a:xfrm>
-            <a:off x="4700000" y="822960"/>
-            <a:ext cx="4000000" cy="914400"/>
+            <a:off x="6053328" y="822960"/>
+            <a:ext cx="2596896" cy="1280160"/>
           </a:xfrm>
           <a:prstGeom prst="rect">
             <a:avLst/>
@@ -8024,7 +8024,7 @@
           <a:p>
             <a:pPr algn="l"/>
             <a:r>
-              <a:rPr lang="ja-JP" sz="2200" b="1" dirty="0">
+              <a:rPr lang="ja-JP" sz="1400" b="1" dirty="0">
                 <a:latin typeface="メイリオ"/>
                 <a:ea typeface="メイリオ"/>
                 <a:cs typeface="メイリオ"/>
@@ -8035,7 +8035,7 @@
           <a:p>
             <a:pPr algn="l"/>
             <a:r>
-              <a:rPr lang="ja-JP" sz="1600" b="0" dirty="0">
+              <a:rPr lang="ja-JP" sz="1100" b="0" dirty="0">
                 <a:latin typeface="メイリオ"/>
                 <a:ea typeface="メイリオ"/>
                 <a:cs typeface="メイリオ"/>
@@ -8059,8 +8059,8 @@
         </p:nvSpPr>
         <p:spPr bwMode="white">
           <a:xfrm>
-            <a:off x="489758" y="2606040"/>
-            <a:ext cx="4000000" cy="914400"/>
+            <a:off x="493776" y="2606040"/>
+            <a:ext cx="3995928" cy="1280160"/>
           </a:xfrm>
           <a:prstGeom prst="rect">
             <a:avLst/>
@@ -8080,7 +8080,7 @@
           <a:p>
             <a:pPr algn="l"/>
             <a:r>
-              <a:rPr lang="ja-JP" sz="2200" b="1" dirty="0">
+              <a:rPr lang="ja-JP" sz="2000" b="1" dirty="0">
                 <a:latin typeface="メイリオ"/>
                 <a:ea typeface="メイリオ"/>
                 <a:cs typeface="メイリオ"/>
@@ -8091,7 +8091,7 @@
           <a:p>
             <a:pPr algn="l"/>
             <a:r>
-              <a:rPr lang="ja-JP" sz="1600" b="0" dirty="0">
+              <a:rPr lang="ja-JP" sz="1400" b="0" dirty="0">
                 <a:latin typeface="メイリオ"/>
                 <a:ea typeface="メイリオ"/>
                 <a:cs typeface="メイリオ"/>
@@ -8115,8 +8115,8 @@
         </p:nvSpPr>
         <p:spPr bwMode="white">
           <a:xfrm>
-            <a:off x="4700000" y="2606040"/>
-            <a:ext cx="4000000" cy="914400"/>
+            <a:off x="493776" y="822960"/>
+            <a:ext cx="2596896" cy="1280160"/>
           </a:xfrm>
           <a:prstGeom prst="rect">
             <a:avLst/>
@@ -8136,7 +8136,7 @@
           <a:p>
             <a:pPr algn="l"/>
             <a:r>
-              <a:rPr lang="ja-JP" sz="2200" b="1" dirty="0">
+              <a:rPr lang="ja-JP" sz="1400" b="1" dirty="0">
                 <a:latin typeface="メイリオ"/>
                 <a:ea typeface="メイリオ"/>
                 <a:cs typeface="メイリオ"/>
@@ -8147,12 +8147,68 @@
           <a:p>
             <a:pPr algn="l"/>
             <a:r>
-              <a:rPr lang="ja-JP" sz="1600" b="0" dirty="0">
+              <a:rPr lang="ja-JP" sz="1100" b="0" dirty="0">
                 <a:latin typeface="メイリオ"/>
                 <a:ea typeface="メイリオ"/>
                 <a:cs typeface="メイリオ"/>
               </a:rPr>
-              <a:t>「けんかをしたけど」</a:t>
+              <a:t>「ともだちとなかよく」</a:t>
+            </a:r>
+          </a:p>
+        </p:txBody>
+      </p:sp>
+      <p:sp>
+        <p:nvSpPr>
+          <p:cNvPr id="9" name="正方形/長方形 8">
+            <a:extLst>
+              <a:ext uri="{FF2B5EF4-FFF2-40B4-BE49-F238E27FC236}">
+                <a16:creationId xmlns:a16="http://schemas.microsoft.com/office/drawing/2014/main" id="{C5D3743F-9B80-8301-2727-28B24CEB585F}"/>
+              </a:ext>
+            </a:extLst>
+          </p:cNvPr>
+          <p:cNvSpPr/>
+          <p:nvPr/>
+        </p:nvSpPr>
+        <p:spPr bwMode="white">
+          <a:xfrm>
+            <a:off x="5038344" y="2606040"/>
+            <a:ext cx="3995928" cy="1280160"/>
+          </a:xfrm>
+          <a:prstGeom prst="rect">
+            <a:avLst/>
+          </a:prstGeom>
+          <a:solidFill>
+            <a:schemeClr val="bg1"/>
+          </a:solidFill>
+          <a:ln>
+            <a:noFill/>
+          </a:ln>
+        </p:spPr>
+        <p:txBody>
+          <a:bodyPr wrap="square">
+            <a:spAutoFit/>
+          </a:bodyPr>
+          <a:lstStyle/>
+          <a:p>
+            <a:pPr algn="l"/>
+            <a:r>
+              <a:rPr lang="ja-JP" sz="2000" b="1" dirty="0">
+                <a:latin typeface="メイリオ"/>
+                <a:ea typeface="メイリオ"/>
+                <a:cs typeface="メイリオ"/>
+              </a:rPr>
+              <a:t>6-2　音楽（見城 麻美）</a:t>
+            </a:r>
+          </a:p>
+          <a:p>
+            <a:pPr algn="l"/>
+            <a:r>
+              <a:rPr lang="ja-JP" sz="1400" b="0" dirty="0">
+                <a:latin typeface="メイリオ"/>
+                <a:ea typeface="メイリオ"/>
+                <a:cs typeface="メイリオ"/>
+              </a:rPr>
+              <a:t>「パートの役割を活かして合奏しよう」</a:t>
             </a:r>
           </a:p>
         </p:txBody>
@@ -13087,7 +13143,7 @@
         <p:spPr bwMode="white">
           <a:xfrm>
             <a:off x="489758" y="658368"/>
-            <a:ext cx="3628642" cy="749808"/>
+            <a:ext cx="3628642" cy="777240"/>
           </a:xfrm>
           <a:prstGeom prst="rect">
             <a:avLst/>
@@ -13107,7 +13163,7 @@
           <a:p>
             <a:pPr algn="l"/>
             <a:r>
-              <a:rPr lang="ja-JP" sz="1800" b="1" dirty="0">
+              <a:rPr lang="ja-JP" sz="1500" b="1" dirty="0">
                 <a:latin typeface="メイリオ"/>
                 <a:ea typeface="メイリオ"/>
                 <a:cs typeface="メイリオ"/>
@@ -13194,7 +13250,7 @@
         <p:spPr bwMode="white">
           <a:xfrm>
             <a:off x="4983758" y="658368"/>
-            <a:ext cx="3571042" cy="749808"/>
+            <a:ext cx="3571042" cy="777240"/>
           </a:xfrm>
           <a:prstGeom prst="rect">
             <a:avLst/>
@@ -13214,7 +13270,7 @@
           <a:p>
             <a:pPr algn="l"/>
             <a:r>
-              <a:rPr lang="ja-JP" sz="2200" b="1" dirty="0">
+              <a:rPr lang="ja-JP" sz="1800" b="1" dirty="0">
                 <a:latin typeface="メイリオ"/>
                 <a:ea typeface="メイリオ"/>
                 <a:cs typeface="メイリオ"/>
@@ -13225,7 +13281,7 @@
           <a:p>
             <a:pPr algn="l"/>
             <a:r>
-              <a:rPr lang="ja-JP" sz="1600" b="0" dirty="0">
+              <a:rPr lang="ja-JP" sz="1400" b="0" dirty="0">
                 <a:latin typeface="メイリオ"/>
                 <a:ea typeface="メイリオ"/>
                 <a:cs typeface="メイリオ"/>
@@ -13286,62 +13342,6 @@
           </a:p>
         </p:txBody>
       </p:sp>
-      <p:sp>
-        <p:nvSpPr>
-          <p:cNvPr id="9" name="正方形/長方形 8">
-            <a:extLst>
-              <a:ext uri="{FF2B5EF4-FFF2-40B4-BE49-F238E27FC236}">
-                <a16:creationId xmlns:a16="http://schemas.microsoft.com/office/drawing/2014/main" id="{77876903-AD43-5597-093C-B3A30EBDBD14}"/>
-              </a:ext>
-            </a:extLst>
-          </p:cNvPr>
-          <p:cNvSpPr/>
-          <p:nvPr/>
-        </p:nvSpPr>
-        <p:spPr bwMode="white">
-          <a:xfrm>
-            <a:off x="493776" y="4343400"/>
-            <a:ext cx="8156448" cy="685800"/>
-          </a:xfrm>
-          <a:prstGeom prst="rect">
-            <a:avLst/>
-          </a:prstGeom>
-          <a:solidFill>
-            <a:schemeClr val="bg1"/>
-          </a:solidFill>
-          <a:ln>
-            <a:noFill/>
-          </a:ln>
-        </p:spPr>
-        <p:txBody>
-          <a:bodyPr wrap="square">
-            <a:spAutoFit/>
-          </a:bodyPr>
-          <a:lstStyle/>
-          <a:p>
-            <a:pPr algn="l"/>
-            <a:r>
-              <a:rPr lang="ja-JP" sz="2000" b="1" dirty="0">
-                <a:latin typeface="メイリオ"/>
-                <a:ea typeface="メイリオ"/>
-                <a:cs typeface="メイリオ"/>
-              </a:rPr>
-              <a:t>5-1　外国語（三宅 真行）</a:t>
-            </a:r>
-          </a:p>
-          <a:p>
-            <a:pPr algn="l"/>
-            <a:r>
-              <a:rPr lang="ja-JP" sz="1400" b="0" dirty="0">
-                <a:latin typeface="メイリオ"/>
-                <a:ea typeface="メイリオ"/>
-                <a:cs typeface="メイリオ"/>
-              </a:rPr>
-              <a:t>Unit２「When is your birthday?」</a:t>
-            </a:r>
-          </a:p>
-        </p:txBody>
-      </p:sp>
     </p:spTree>
     <p:extLst>
       <p:ext uri="{BB962C8B-B14F-4D97-AF65-F5344CB8AC3E}">
@@ -13356,28 +13356,15 @@
 </file>
 
 <file path=ppt/slides/slide8.xml><?xml version="1.0" encoding="utf-8"?>
-<p:sld xmlns:a="http://schemas.openxmlformats.org/drawingml/2006/main" xmlns:r="http://schemas.openxmlformats.org/officeDocument/2006/relationships" xmlns:p="http://schemas.openxmlformats.org/presentationml/2006/main">
+<p:sld xmlns:a="http://schemas.openxmlformats.org/drawingml/2006/main" xmlns:p="http://schemas.openxmlformats.org/presentationml/2006/main" xmlns:r="http://schemas.openxmlformats.org/officeDocument/2006/relationships">
   <p:cSld>
     <p:spTree>
       <p:nvGrpSpPr>
-        <p:cNvPr id="1" name="">
-          <a:extLst>
-            <a:ext uri="{FF2B5EF4-FFF2-40B4-BE49-F238E27FC236}">
-              <a16:creationId xmlns:a16="http://schemas.microsoft.com/office/drawing/2014/main" id="{5435304E-5B76-C7D3-FF30-435E1F2E4498}"/>
-            </a:ext>
-          </a:extLst>
-        </p:cNvPr>
+        <p:cNvPr id="1" name=""/>
         <p:cNvGrpSpPr/>
         <p:nvPr/>
       </p:nvGrpSpPr>
-      <p:grpSpPr>
-        <a:xfrm>
-          <a:off x="0" y="0"/>
-          <a:ext cx="0" cy="0"/>
-          <a:chOff x="0" y="0"/>
-          <a:chExt cx="0" cy="0"/>
-        </a:xfrm>
-      </p:grpSpPr>
+      <p:grpSpPr/>
       <p:sp>
         <p:nvSpPr>
           <p:cNvPr id="8" name="正方形/長方形 7">
@@ -13468,7 +13455,7 @@
                 <a:ea typeface="メイリオ"/>
                 <a:cs typeface="メイリオ"/>
               </a:rPr>
-              <a:t>　３・４校時の授業について　②考え</a:t>
+              <a:t>　３・４校時の授業について　①関心</a:t>
             </a:r>
             <a:endParaRPr lang="en-US" altLang="ja-JP" sz="3200" b="1" dirty="0">
               <a:solidFill>
@@ -13492,8 +13479,8 @@
         </p:nvSpPr>
         <p:spPr bwMode="white">
           <a:xfrm>
-            <a:off x="489758" y="822960"/>
-            <a:ext cx="4000000" cy="914400"/>
+            <a:off x="274320" y="822960"/>
+            <a:ext cx="8595360" cy="777240"/>
           </a:xfrm>
           <a:prstGeom prst="rect">
             <a:avLst/>
@@ -13518,7 +13505,7 @@
                 <a:ea typeface="メイリオ"/>
                 <a:cs typeface="メイリオ"/>
               </a:rPr>
-              <a:t>2-1　算数（岩佐 沙恵子）</a:t>
+              <a:t>3年　算数「たし算とひき算の筆算」</a:t>
             </a:r>
           </a:p>
           <a:p>
@@ -13529,7 +13516,7 @@
                 <a:ea typeface="メイリオ"/>
                 <a:cs typeface="メイリオ"/>
               </a:rPr>
-              <a:t>「長さのたんい」</a:t>
+              <a:t>４学級で展開</a:t>
             </a:r>
           </a:p>
         </p:txBody>
@@ -13548,8 +13535,8 @@
         </p:nvSpPr>
         <p:spPr bwMode="white">
           <a:xfrm>
-            <a:off x="4700000" y="822960"/>
-            <a:ext cx="4000000" cy="914400"/>
+            <a:off x="4663440" y="1920240"/>
+            <a:ext cx="2011680" cy="1005840"/>
           </a:xfrm>
           <a:prstGeom prst="rect">
             <a:avLst/>
@@ -13567,25 +13554,25 @@
           </a:bodyPr>
           <a:lstStyle/>
           <a:p>
-            <a:pPr algn="l"/>
-            <a:r>
-              <a:rPr lang="ja-JP" sz="2200" b="1" dirty="0">
+            <a:pPr algn="ctr"/>
+            <a:r>
+              <a:rPr lang="ja-JP" sz="2000" b="1" dirty="0">
                 <a:latin typeface="メイリオ"/>
                 <a:ea typeface="メイリオ"/>
                 <a:cs typeface="メイリオ"/>
               </a:rPr>
-              <a:t>5-3　社会（小松 沙織）</a:t>
-            </a:r>
-          </a:p>
-          <a:p>
-            <a:pPr algn="l"/>
-            <a:r>
-              <a:rPr lang="ja-JP" sz="1400" b="0" dirty="0">
+              <a:t>3-3</a:t>
+            </a:r>
+          </a:p>
+          <a:p>
+            <a:pPr algn="ctr"/>
+            <a:r>
+              <a:rPr lang="ja-JP" sz="1600" b="0" dirty="0">
                 <a:latin typeface="メイリオ"/>
                 <a:ea typeface="メイリオ"/>
                 <a:cs typeface="メイリオ"/>
               </a:rPr>
-              <a:t>「日本の国土とわたしたちのくらし」</a:t>
+              <a:t>伊藤 蘭</a:t>
             </a:r>
           </a:p>
         </p:txBody>
@@ -13604,8 +13591,8 @@
         </p:nvSpPr>
         <p:spPr bwMode="white">
           <a:xfrm>
-            <a:off x="489758" y="2606040"/>
-            <a:ext cx="4000000" cy="914400"/>
+            <a:off x="1371600" y="3383280"/>
+            <a:ext cx="6400800" cy="1005840"/>
           </a:xfrm>
           <a:prstGeom prst="rect">
             <a:avLst/>
@@ -13625,12 +13612,12 @@
           <a:p>
             <a:pPr algn="l"/>
             <a:r>
-              <a:rPr lang="ja-JP" sz="2200" b="1" dirty="0">
+              <a:rPr lang="ja-JP" sz="1800" b="1" dirty="0">
                 <a:latin typeface="メイリオ"/>
                 <a:ea typeface="メイリオ"/>
                 <a:cs typeface="メイリオ"/>
               </a:rPr>
-              <a:t>4-2　国語（工藤 由利）</a:t>
+              <a:t>課題の設定</a:t>
             </a:r>
           </a:p>
           <a:p>
@@ -13641,17 +13628,17 @@
                 <a:ea typeface="メイリオ"/>
                 <a:cs typeface="メイリオ"/>
               </a:rPr>
-              <a:t>「筆者の考えをとらえて自分の考えを発表しよう」</a:t>
-            </a:r>
-          </a:p>
-        </p:txBody>
-      </p:sp>
-      <p:sp>
-        <p:nvSpPr>
-          <p:cNvPr id="5" name="正方形/長方形 4">
+              <a:t>「1000円札を出したときのおつり」（買い物文脈）</a:t>
+            </a:r>
+          </a:p>
+        </p:txBody>
+      </p:sp>
+      <p:sp>
+        <p:nvSpPr>
+          <p:cNvPr id="9" name="正方形/長方形 8">
             <a:extLst>
               <a:ext uri="{FF2B5EF4-FFF2-40B4-BE49-F238E27FC236}">
-                <a16:creationId xmlns:a16="http://schemas.microsoft.com/office/drawing/2014/main" id="{FD58072C-8A99-B42C-4A03-380C420A0218}"/>
+                <a16:creationId xmlns:a16="http://schemas.microsoft.com/office/drawing/2014/main" id="{C871D856-5C1D-8BEB-D3E7-9B8F19D3E72D}"/>
               </a:ext>
             </a:extLst>
           </p:cNvPr>
@@ -13660,8 +13647,8 @@
         </p:nvSpPr>
         <p:spPr bwMode="white">
           <a:xfrm>
-            <a:off x="4700000" y="2606040"/>
-            <a:ext cx="4000000" cy="914400"/>
+            <a:off x="2468879" y="1920240"/>
+            <a:ext cx="2011680" cy="1005840"/>
           </a:xfrm>
           <a:prstGeom prst="rect">
             <a:avLst/>
@@ -13679,35 +13666,142 @@
           </a:bodyPr>
           <a:lstStyle/>
           <a:p>
-            <a:pPr algn="l"/>
-            <a:r>
-              <a:rPr lang="ja-JP" sz="2200" b="1" dirty="0">
+            <a:pPr algn="ctr"/>
+            <a:r>
+              <a:rPr lang="ja-JP" sz="2000" b="1" dirty="0">
                 <a:latin typeface="メイリオ"/>
                 <a:ea typeface="メイリオ"/>
                 <a:cs typeface="メイリオ"/>
               </a:rPr>
-              <a:t>6-3　道徳（松田 容子）</a:t>
-            </a:r>
-          </a:p>
-          <a:p>
-            <a:pPr algn="l"/>
+              <a:t>3-2</a:t>
+            </a:r>
+          </a:p>
+          <a:p>
+            <a:pPr algn="ctr"/>
             <a:r>
               <a:rPr lang="ja-JP" sz="1600" b="0" dirty="0">
                 <a:latin typeface="メイリオ"/>
                 <a:ea typeface="メイリオ"/>
                 <a:cs typeface="メイリオ"/>
               </a:rPr>
-              <a:t>「子ども会のキャンプ」</a:t>
+              <a:t>岡﨑 智子</a:t>
+            </a:r>
+          </a:p>
+        </p:txBody>
+      </p:sp>
+      <p:sp>
+        <p:nvSpPr>
+          <p:cNvPr id="9" name="正方形/長方形 8">
+            <a:extLst>
+              <a:ext uri="{FF2B5EF4-FFF2-40B4-BE49-F238E27FC236}">
+                <a16:creationId xmlns:a16="http://schemas.microsoft.com/office/drawing/2014/main" id="{C871D856-5C1D-8BEB-D3E7-9B8F19D3E72D}"/>
+              </a:ext>
+            </a:extLst>
+          </p:cNvPr>
+          <p:cNvSpPr/>
+          <p:nvPr/>
+        </p:nvSpPr>
+        <p:spPr bwMode="white">
+          <a:xfrm>
+            <a:off x="274320" y="1920240"/>
+            <a:ext cx="2011680" cy="1005840"/>
+          </a:xfrm>
+          <a:prstGeom prst="rect">
+            <a:avLst/>
+          </a:prstGeom>
+          <a:solidFill>
+            <a:schemeClr val="bg1"/>
+          </a:solidFill>
+          <a:ln>
+            <a:noFill/>
+          </a:ln>
+        </p:spPr>
+        <p:txBody>
+          <a:bodyPr wrap="square">
+            <a:spAutoFit/>
+          </a:bodyPr>
+          <a:lstStyle/>
+          <a:p>
+            <a:pPr algn="ctr"/>
+            <a:r>
+              <a:rPr lang="ja-JP" sz="2000" b="1" dirty="0">
+                <a:latin typeface="メイリオ"/>
+                <a:ea typeface="メイリオ"/>
+                <a:cs typeface="メイリオ"/>
+              </a:rPr>
+              <a:t>3-1</a:t>
+            </a:r>
+          </a:p>
+          <a:p>
+            <a:pPr algn="ctr"/>
+            <a:r>
+              <a:rPr lang="ja-JP" sz="1600" b="0" dirty="0">
+                <a:latin typeface="メイリオ"/>
+                <a:ea typeface="メイリオ"/>
+                <a:cs typeface="メイリオ"/>
+              </a:rPr>
+              <a:t>間 勇人</a:t>
+            </a:r>
+          </a:p>
+        </p:txBody>
+      </p:sp>
+      <p:sp>
+        <p:nvSpPr>
+          <p:cNvPr id="9" name="正方形/長方形 8">
+            <a:extLst>
+              <a:ext uri="{FF2B5EF4-FFF2-40B4-BE49-F238E27FC236}">
+                <a16:creationId xmlns:a16="http://schemas.microsoft.com/office/drawing/2014/main" id="{C871D856-5C1D-8BEB-D3E7-9B8F19D3E72D}"/>
+              </a:ext>
+            </a:extLst>
+          </p:cNvPr>
+          <p:cNvSpPr/>
+          <p:nvPr/>
+        </p:nvSpPr>
+        <p:spPr bwMode="white">
+          <a:xfrm>
+            <a:off x="6858000" y="1920240"/>
+            <a:ext cx="2011680" cy="1005840"/>
+          </a:xfrm>
+          <a:prstGeom prst="rect">
+            <a:avLst/>
+          </a:prstGeom>
+          <a:solidFill>
+            <a:schemeClr val="bg1"/>
+          </a:solidFill>
+          <a:ln>
+            <a:noFill/>
+          </a:ln>
+        </p:spPr>
+        <p:txBody>
+          <a:bodyPr wrap="square">
+            <a:spAutoFit/>
+          </a:bodyPr>
+          <a:lstStyle/>
+          <a:p>
+            <a:pPr algn="ctr"/>
+            <a:r>
+              <a:rPr lang="ja-JP" sz="2000" b="1" dirty="0">
+                <a:latin typeface="メイリオ"/>
+                <a:ea typeface="メイリオ"/>
+                <a:cs typeface="メイリオ"/>
+              </a:rPr>
+              <a:t>少人数</a:t>
+            </a:r>
+          </a:p>
+          <a:p>
+            <a:pPr algn="ctr"/>
+            <a:r>
+              <a:rPr lang="ja-JP" sz="1600" b="0" dirty="0">
+                <a:latin typeface="メイリオ"/>
+                <a:ea typeface="メイリオ"/>
+                <a:cs typeface="メイリオ"/>
+              </a:rPr>
+              <a:t>鈴木 寛</a:t>
             </a:r>
           </a:p>
         </p:txBody>
       </p:sp>
     </p:spTree>
-    <p:extLst>
-      <p:ext uri="{BB962C8B-B14F-4D97-AF65-F5344CB8AC3E}">
-        <p14:creationId xmlns:p14="http://schemas.microsoft.com/office/powerpoint/2010/main" val="660057930"/>
-      </p:ext>
-    </p:extLst>
   </p:cSld>
   <p:clrMapOvr>
     <a:masterClrMapping/>
@@ -13716,15 +13810,28 @@
 </file>
 
 <file path=ppt/slides/slide9.xml><?xml version="1.0" encoding="utf-8"?>
-<p:sld xmlns:a="http://schemas.openxmlformats.org/drawingml/2006/main" xmlns:p="http://schemas.openxmlformats.org/presentationml/2006/main" xmlns:r="http://schemas.openxmlformats.org/officeDocument/2006/relationships">
+<p:sld xmlns:a="http://schemas.openxmlformats.org/drawingml/2006/main" xmlns:r="http://schemas.openxmlformats.org/officeDocument/2006/relationships" xmlns:p="http://schemas.openxmlformats.org/presentationml/2006/main">
   <p:cSld>
     <p:spTree>
       <p:nvGrpSpPr>
-        <p:cNvPr id="1" name=""/>
+        <p:cNvPr id="1" name="">
+          <a:extLst>
+            <a:ext uri="{FF2B5EF4-FFF2-40B4-BE49-F238E27FC236}">
+              <a16:creationId xmlns:a16="http://schemas.microsoft.com/office/drawing/2014/main" id="{5435304E-5B76-C7D3-FF30-435E1F2E4498}"/>
+            </a:ext>
+          </a:extLst>
+        </p:cNvPr>
         <p:cNvGrpSpPr/>
         <p:nvPr/>
       </p:nvGrpSpPr>
-      <p:grpSpPr/>
+      <p:grpSpPr>
+        <a:xfrm>
+          <a:off x="0" y="0"/>
+          <a:ext cx="0" cy="0"/>
+          <a:chOff x="0" y="0"/>
+          <a:chExt cx="0" cy="0"/>
+        </a:xfrm>
+      </p:grpSpPr>
       <p:sp>
         <p:nvSpPr>
           <p:cNvPr id="8" name="正方形/長方形 7">
@@ -13839,8 +13946,8 @@
         </p:nvSpPr>
         <p:spPr bwMode="white">
           <a:xfrm>
-            <a:off x="274320" y="777240"/>
-            <a:ext cx="8595360" cy="685800"/>
+            <a:off x="489758" y="822960"/>
+            <a:ext cx="4000000" cy="914400"/>
           </a:xfrm>
           <a:prstGeom prst="rect">
             <a:avLst/>
@@ -13865,7 +13972,7 @@
                 <a:ea typeface="メイリオ"/>
                 <a:cs typeface="メイリオ"/>
               </a:rPr>
-              <a:t>3年　算数「たし算とひき算の筆算」</a:t>
+              <a:t>2-1　算数（岩佐 沙恵子）</a:t>
             </a:r>
           </a:p>
           <a:p>
@@ -13876,7 +13983,7 @@
                 <a:ea typeface="メイリオ"/>
                 <a:cs typeface="メイリオ"/>
               </a:rPr>
-              <a:t>４学級で展開</a:t>
+              <a:t>「長さのたんい」</a:t>
             </a:r>
           </a:p>
         </p:txBody>
@@ -13895,8 +14002,8 @@
         </p:nvSpPr>
         <p:spPr bwMode="white">
           <a:xfrm>
-            <a:off x="4663440" y="1600200"/>
-            <a:ext cx="2011680" cy="777240"/>
+            <a:off x="4700000" y="822960"/>
+            <a:ext cx="4000000" cy="914400"/>
           </a:xfrm>
           <a:prstGeom prst="rect">
             <a:avLst/>
@@ -13914,25 +14021,25 @@
           </a:bodyPr>
           <a:lstStyle/>
           <a:p>
-            <a:pPr algn="ctr"/>
-            <a:r>
-              <a:rPr lang="ja-JP" sz="2000" b="1" dirty="0">
+            <a:pPr algn="l"/>
+            <a:r>
+              <a:rPr lang="ja-JP" sz="2200" b="1" dirty="0">
                 <a:latin typeface="メイリオ"/>
                 <a:ea typeface="メイリオ"/>
                 <a:cs typeface="メイリオ"/>
               </a:rPr>
-              <a:t>3-3</a:t>
-            </a:r>
-          </a:p>
-          <a:p>
-            <a:pPr algn="ctr"/>
-            <a:r>
-              <a:rPr lang="ja-JP" sz="1600" b="0" dirty="0">
+              <a:t>5-3　社会（小松 沙織）</a:t>
+            </a:r>
+          </a:p>
+          <a:p>
+            <a:pPr algn="l"/>
+            <a:r>
+              <a:rPr lang="ja-JP" sz="1400" b="0" dirty="0">
                 <a:latin typeface="メイリオ"/>
                 <a:ea typeface="メイリオ"/>
                 <a:cs typeface="メイリオ"/>
               </a:rPr>
-              <a:t>伊藤 蘭</a:t>
+              <a:t>「日本の国土とわたしたちのくらし」</a:t>
             </a:r>
           </a:p>
         </p:txBody>
@@ -13951,8 +14058,8 @@
         </p:nvSpPr>
         <p:spPr bwMode="white">
           <a:xfrm>
-            <a:off x="6858000" y="1600200"/>
-            <a:ext cx="2011680" cy="777240"/>
+            <a:off x="489758" y="2606040"/>
+            <a:ext cx="4000000" cy="914400"/>
           </a:xfrm>
           <a:prstGeom prst="rect">
             <a:avLst/>
@@ -13970,25 +14077,25 @@
           </a:bodyPr>
           <a:lstStyle/>
           <a:p>
-            <a:pPr algn="ctr"/>
-            <a:r>
-              <a:rPr lang="ja-JP" sz="2000" b="1" dirty="0">
+            <a:pPr algn="l"/>
+            <a:r>
+              <a:rPr lang="ja-JP" sz="2200" b="1" dirty="0">
                 <a:latin typeface="メイリオ"/>
                 <a:ea typeface="メイリオ"/>
                 <a:cs typeface="メイリオ"/>
               </a:rPr>
-              <a:t>少人数</a:t>
-            </a:r>
-          </a:p>
-          <a:p>
-            <a:pPr algn="ctr"/>
+              <a:t>4-2　国語（工藤 由利）</a:t>
+            </a:r>
+          </a:p>
+          <a:p>
+            <a:pPr algn="l"/>
             <a:r>
               <a:rPr lang="ja-JP" sz="1600" b="0" dirty="0">
                 <a:latin typeface="メイリオ"/>
                 <a:ea typeface="メイリオ"/>
                 <a:cs typeface="メイリオ"/>
               </a:rPr>
-              <a:t>鈴木 寛</a:t>
+              <a:t>「アップとルーズで伝える」</a:t>
             </a:r>
           </a:p>
         </p:txBody>
@@ -14007,8 +14114,8 @@
         </p:nvSpPr>
         <p:spPr bwMode="white">
           <a:xfrm>
-            <a:off x="1371600" y="2926080"/>
-            <a:ext cx="6400800" cy="1097280"/>
+            <a:off x="4700000" y="2606040"/>
+            <a:ext cx="4000000" cy="914400"/>
           </a:xfrm>
           <a:prstGeom prst="rect">
             <a:avLst/>
@@ -14033,7 +14140,7 @@
                 <a:ea typeface="メイリオ"/>
                 <a:cs typeface="メイリオ"/>
               </a:rPr>
-              <a:t>6年　音楽（見城 麻美）</a:t>
+              <a:t>6-3　道徳（松田 容子）</a:t>
             </a:r>
           </a:p>
           <a:p>
@@ -14044,124 +14151,17 @@
                 <a:ea typeface="メイリオ"/>
                 <a:cs typeface="メイリオ"/>
               </a:rPr>
-              <a:t>「パートの役割を活かして合奏しよう」</a:t>
-            </a:r>
-          </a:p>
-        </p:txBody>
-      </p:sp>
-      <p:sp>
-        <p:nvSpPr>
-          <p:cNvPr id="9" name="正方形/長方形 8">
-            <a:extLst>
-              <a:ext uri="{FF2B5EF4-FFF2-40B4-BE49-F238E27FC236}">
-                <a16:creationId xmlns:a16="http://schemas.microsoft.com/office/drawing/2014/main" id="{C871D856-5C1D-8BEB-D3E7-9B8F19D3E72D}"/>
-              </a:ext>
-            </a:extLst>
-          </p:cNvPr>
-          <p:cNvSpPr/>
-          <p:nvPr/>
-        </p:nvSpPr>
-        <p:spPr bwMode="white">
-          <a:xfrm>
-            <a:off x="2468880" y="1600200"/>
-            <a:ext cx="2011680" cy="777240"/>
-          </a:xfrm>
-          <a:prstGeom prst="rect">
-            <a:avLst/>
-          </a:prstGeom>
-          <a:solidFill>
-            <a:schemeClr val="bg1"/>
-          </a:solidFill>
-          <a:ln>
-            <a:noFill/>
-          </a:ln>
-        </p:spPr>
-        <p:txBody>
-          <a:bodyPr wrap="square">
-            <a:spAutoFit/>
-          </a:bodyPr>
-          <a:lstStyle/>
-          <a:p>
-            <a:pPr algn="ctr"/>
-            <a:r>
-              <a:rPr lang="ja-JP" sz="2000" b="1" dirty="0">
-                <a:latin typeface="メイリオ"/>
-                <a:ea typeface="メイリオ"/>
-                <a:cs typeface="メイリオ"/>
-              </a:rPr>
-              <a:t>3-2</a:t>
-            </a:r>
-          </a:p>
-          <a:p>
-            <a:pPr algn="ctr"/>
-            <a:r>
-              <a:rPr lang="ja-JP" sz="1600" b="0" dirty="0">
-                <a:latin typeface="メイリオ"/>
-                <a:ea typeface="メイリオ"/>
-                <a:cs typeface="メイリオ"/>
-              </a:rPr>
-              <a:t>岡﨑 智子</a:t>
-            </a:r>
-          </a:p>
-        </p:txBody>
-      </p:sp>
-      <p:sp>
-        <p:nvSpPr>
-          <p:cNvPr id="9" name="正方形/長方形 8">
-            <a:extLst>
-              <a:ext uri="{FF2B5EF4-FFF2-40B4-BE49-F238E27FC236}">
-                <a16:creationId xmlns:a16="http://schemas.microsoft.com/office/drawing/2014/main" id="{C871D856-5C1D-8BEB-D3E7-9B8F19D3E72D}"/>
-              </a:ext>
-            </a:extLst>
-          </p:cNvPr>
-          <p:cNvSpPr/>
-          <p:nvPr/>
-        </p:nvSpPr>
-        <p:spPr bwMode="white">
-          <a:xfrm>
-            <a:off x="274320" y="1600200"/>
-            <a:ext cx="2011680" cy="777240"/>
-          </a:xfrm>
-          <a:prstGeom prst="rect">
-            <a:avLst/>
-          </a:prstGeom>
-          <a:solidFill>
-            <a:schemeClr val="bg1"/>
-          </a:solidFill>
-          <a:ln>
-            <a:noFill/>
-          </a:ln>
-        </p:spPr>
-        <p:txBody>
-          <a:bodyPr wrap="square">
-            <a:spAutoFit/>
-          </a:bodyPr>
-          <a:lstStyle/>
-          <a:p>
-            <a:pPr algn="ctr"/>
-            <a:r>
-              <a:rPr lang="ja-JP" sz="2000" b="1" dirty="0">
-                <a:latin typeface="メイリオ"/>
-                <a:ea typeface="メイリオ"/>
-                <a:cs typeface="メイリオ"/>
-              </a:rPr>
-              <a:t>3-1</a:t>
-            </a:r>
-          </a:p>
-          <a:p>
-            <a:pPr algn="ctr"/>
-            <a:r>
-              <a:rPr lang="ja-JP" sz="1600" b="0" dirty="0">
-                <a:latin typeface="メイリオ"/>
-                <a:ea typeface="メイリオ"/>
-                <a:cs typeface="メイリオ"/>
-              </a:rPr>
-              <a:t>間 勇人</a:t>
+              <a:t>「自分の役割を果たす」</a:t>
             </a:r>
           </a:p>
         </p:txBody>
       </p:sp>
     </p:spTree>
+    <p:extLst>
+      <p:ext uri="{BB962C8B-B14F-4D97-AF65-F5344CB8AC3E}">
+        <p14:creationId xmlns:p14="http://schemas.microsoft.com/office/powerpoint/2010/main" val="660057930"/>
+      </p:ext>
+    </p:extLst>
   </p:cSld>
   <p:clrMapOvr>
     <a:masterClrMapping/>

</xml_diff>

<commit_message>
Add 三宅先生 back + insert 2 ICT activation slides in まとめ
PPTX changes:
- Slide 7: Re-add 5-1外国語(三宅 真行) at bottom + Unit2 "When is your birthday?"
- Slide 15: NEW - ICTの効果的な活用事例 (children using tablets, from previous upload)
- Slide 16: NEW - 今後のICT活用に向けて (3 directions: 個別最適/協働的/教師の見取り)
- Total: 17 slides (was 15)

Script (.md + .docx) changes:
- 三宅先生 commentary added under 手だて①その1 (~25 sec)
  → 誕生月を扱う personal hook, Small Talk導入
- 2 new ICT sections (each ~20 sec):
  → ICTの効果的な活用事例: 試行錯誤しながら自分に合った方法
  → 今後のICT活用: 個別最適/協働的/教師の見取りの3方向
- Rebalanced timing to stay at 10:00
- All 17 teachers now covered (was 16)

Verification:
- 全17名(13単元): 1年体育3名+3年算数4名+9個別単元
- 講評時間: 6:05 (61%)
- ICT解説: 40秒
- 合計: 10:00

https://claude.ai/code/session_0115j5ByNrFwaiK1mMDykaCF
</commit_message>
<xml_diff>
--- a/output/★指導課訪問★３・４校時指導助言資料（例）.pptx
+++ b/output/★指導課訪問★３・４校時指導助言資料（例）.pptx
@@ -25,6 +25,8 @@
     <p:sldId id="521" r:id="rId12"/>
     <p:sldId id="728" r:id="rId13"/>
     <p:sldId id="355" r:id="rId14"/>
+    <p:sldId id="733" r:id="rId23"/>
+    <p:sldId id="734" r:id="rId24"/>
     <p:sldId id="727" r:id="rId15"/>
   </p:sldIdLst>
   <p:sldSz cx="9144000" cy="5143500" type="screen16x9"/>
@@ -10334,6 +10336,638 @@
 </file>
 
 <file path=ppt/slides/slide15.xml><?xml version="1.0" encoding="utf-8"?>
+<p:sld xmlns:a="http://schemas.openxmlformats.org/drawingml/2006/main" xmlns:p="http://schemas.openxmlformats.org/presentationml/2006/main" xmlns:r="http://schemas.openxmlformats.org/officeDocument/2006/relationships">
+  <p:cSld>
+    <p:spTree>
+      <p:nvGrpSpPr>
+        <p:cNvPr id="1" name=""/>
+        <p:cNvGrpSpPr/>
+        <p:nvPr/>
+      </p:nvGrpSpPr>
+      <p:grpSpPr/>
+      <p:sp>
+        <p:nvSpPr>
+          <p:cNvPr id="2" name="Rectangle 1"/>
+          <p:cNvSpPr/>
+          <p:nvPr/>
+        </p:nvSpPr>
+        <p:spPr>
+          <a:xfrm>
+            <a:off x="0" y="0"/>
+            <a:ext cx="9144000" cy="612648"/>
+          </a:xfrm>
+          <a:prstGeom prst="rect">
+            <a:avLst/>
+          </a:prstGeom>
+          <a:solidFill>
+            <a:srgbClr val="5B9BD5"/>
+          </a:solidFill>
+          <a:ln>
+            <a:noFill/>
+          </a:ln>
+        </p:spPr>
+        <p:style>
+          <a:lnRef idx="1">
+            <a:schemeClr val="accent1"/>
+          </a:lnRef>
+          <a:fillRef idx="3">
+            <a:schemeClr val="accent1"/>
+          </a:fillRef>
+          <a:effectRef idx="2">
+            <a:schemeClr val="accent1"/>
+          </a:effectRef>
+          <a:fontRef idx="minor">
+            <a:schemeClr val="lt1"/>
+          </a:fontRef>
+        </p:style>
+        <p:txBody>
+          <a:bodyPr rtlCol="0" anchor="ctr"/>
+          <a:lstStyle/>
+          <a:p>
+            <a:pPr algn="ctr"/>
+            <a:r>
+              <a:rPr lang="ja-JP" sz="3200" b="1" dirty="0">
+                <a:solidFill>
+                  <a:srgbClr val="FFFFFF"/>
+                </a:solidFill>
+                <a:latin typeface="メイリオ"/>
+                <a:ea typeface="メイリオ"/>
+                <a:cs typeface="メイリオ"/>
+              </a:rPr>
+              <a:t>　まとめ（今後に向けて）　ICTの活用①</a:t>
+            </a:r>
+          </a:p>
+        </p:txBody>
+      </p:sp>
+      <p:pic>
+        <p:nvPicPr>
+          <p:cNvPr id="3" name="Picture 2" descr="image.png"/>
+          <p:cNvPicPr>
+            <a:picLocks noChangeAspect="1"/>
+          </p:cNvPicPr>
+          <p:nvPr/>
+        </p:nvPicPr>
+        <p:blipFill>
+          <a:blip r:embed="rId2"/>
+          <a:stretch>
+            <a:fillRect/>
+          </a:stretch>
+        </p:blipFill>
+        <p:spPr>
+          <a:xfrm>
+            <a:off x="1371600" y="914400"/>
+            <a:ext cx="6400800" cy="3383280"/>
+          </a:xfrm>
+          <a:prstGeom prst="rect">
+            <a:avLst/>
+          </a:prstGeom>
+        </p:spPr>
+      </p:pic>
+      <p:sp>
+        <p:nvSpPr>
+          <p:cNvPr id="4" name="TextBox 3"/>
+          <p:cNvSpPr txBox="1"/>
+          <p:nvPr/>
+        </p:nvSpPr>
+        <p:spPr>
+          <a:xfrm>
+            <a:off x="457200" y="4434840"/>
+            <a:ext cx="8229600" cy="502920"/>
+          </a:xfrm>
+          <a:prstGeom prst="rect">
+            <a:avLst/>
+          </a:prstGeom>
+          <a:noFill/>
+        </p:spPr>
+        <p:txBody>
+          <a:bodyPr wrap="square">
+            <a:spAutoFit/>
+          </a:bodyPr>
+          <a:lstStyle/>
+          <a:p>
+            <a:pPr algn="ctr"/>
+            <a:r>
+              <a:rPr lang="ja-JP" sz="1800" b="1" dirty="0">
+                <a:solidFill>
+                  <a:srgbClr val="1F4E79"/>
+                </a:solidFill>
+                <a:latin typeface="メイリオ"/>
+                <a:ea typeface="メイリオ"/>
+                <a:cs typeface="メイリオ"/>
+              </a:rPr>
+              <a:t>個別最適な学びと協働的な学びの一体的な充実</a:t>
+            </a:r>
+          </a:p>
+        </p:txBody>
+      </p:sp>
+    </p:spTree>
+  </p:cSld>
+  <p:clrMapOvr>
+    <a:masterClrMapping/>
+  </p:clrMapOvr>
+</p:sld>
+</file>
+
+<file path=ppt/slides/slide16.xml><?xml version="1.0" encoding="utf-8"?>
+<p:sld xmlns:a="http://schemas.openxmlformats.org/drawingml/2006/main" xmlns:p="http://schemas.openxmlformats.org/presentationml/2006/main" xmlns:r="http://schemas.openxmlformats.org/officeDocument/2006/relationships">
+  <p:cSld>
+    <p:spTree>
+      <p:nvGrpSpPr>
+        <p:cNvPr id="1" name=""/>
+        <p:cNvGrpSpPr/>
+        <p:nvPr/>
+      </p:nvGrpSpPr>
+      <p:grpSpPr/>
+      <p:sp>
+        <p:nvSpPr>
+          <p:cNvPr id="2" name="Rectangle 1"/>
+          <p:cNvSpPr/>
+          <p:nvPr/>
+        </p:nvSpPr>
+        <p:spPr>
+          <a:xfrm>
+            <a:off x="0" y="0"/>
+            <a:ext cx="9144000" cy="612648"/>
+          </a:xfrm>
+          <a:prstGeom prst="rect">
+            <a:avLst/>
+          </a:prstGeom>
+          <a:solidFill>
+            <a:srgbClr val="5B9BD5"/>
+          </a:solidFill>
+          <a:ln>
+            <a:noFill/>
+          </a:ln>
+        </p:spPr>
+        <p:style>
+          <a:lnRef idx="1">
+            <a:schemeClr val="accent1"/>
+          </a:lnRef>
+          <a:fillRef idx="3">
+            <a:schemeClr val="accent1"/>
+          </a:fillRef>
+          <a:effectRef idx="2">
+            <a:schemeClr val="accent1"/>
+          </a:effectRef>
+          <a:fontRef idx="minor">
+            <a:schemeClr val="lt1"/>
+          </a:fontRef>
+        </p:style>
+        <p:txBody>
+          <a:bodyPr rtlCol="0" anchor="ctr"/>
+          <a:lstStyle/>
+          <a:p>
+            <a:pPr algn="ctr"/>
+            <a:r>
+              <a:rPr lang="ja-JP" sz="3200" b="1" dirty="0">
+                <a:solidFill>
+                  <a:srgbClr val="FFFFFF"/>
+                </a:solidFill>
+                <a:latin typeface="メイリオ"/>
+                <a:ea typeface="メイリオ"/>
+                <a:cs typeface="メイリオ"/>
+              </a:rPr>
+              <a:t>　まとめ（今後に向けて）　ICTの活用</a:t>
+            </a:r>
+          </a:p>
+        </p:txBody>
+      </p:sp>
+      <p:sp>
+        <p:nvSpPr>
+          <p:cNvPr id="3" name="TextBox 2"/>
+          <p:cNvSpPr txBox="1"/>
+          <p:nvPr/>
+        </p:nvSpPr>
+        <p:spPr>
+          <a:xfrm>
+            <a:off x="457200" y="777240"/>
+            <a:ext cx="8229600" cy="548640"/>
+          </a:xfrm>
+          <a:prstGeom prst="rect">
+            <a:avLst/>
+          </a:prstGeom>
+          <a:noFill/>
+        </p:spPr>
+        <p:txBody>
+          <a:bodyPr wrap="square">
+            <a:spAutoFit/>
+          </a:bodyPr>
+          <a:lstStyle/>
+          <a:p>
+            <a:pPr algn="ctr"/>
+            <a:r>
+              <a:rPr lang="ja-JP" sz="2400" b="1" dirty="0">
+                <a:solidFill>
+                  <a:srgbClr val="1F4E79"/>
+                </a:solidFill>
+                <a:latin typeface="メイリオ"/>
+                <a:ea typeface="メイリオ"/>
+                <a:cs typeface="メイリオ"/>
+              </a:rPr>
+              <a:t>今後のICT活用に向けて</a:t>
+            </a:r>
+          </a:p>
+        </p:txBody>
+      </p:sp>
+      <p:sp>
+        <p:nvSpPr>
+          <p:cNvPr id="4" name="Rectangle 3"/>
+          <p:cNvSpPr/>
+          <p:nvPr/>
+        </p:nvSpPr>
+        <p:spPr>
+          <a:xfrm>
+            <a:off x="457200" y="1554480"/>
+            <a:ext cx="8229600" cy="960120"/>
+          </a:xfrm>
+          <a:prstGeom prst="rect">
+            <a:avLst/>
+          </a:prstGeom>
+          <a:solidFill>
+            <a:srgbClr val="E8F1FA"/>
+          </a:solidFill>
+          <a:ln w="19050">
+            <a:solidFill>
+              <a:srgbClr val="5B9BD5"/>
+            </a:solidFill>
+          </a:ln>
+        </p:spPr>
+        <p:style>
+          <a:lnRef idx="1">
+            <a:schemeClr val="accent1"/>
+          </a:lnRef>
+          <a:fillRef idx="3">
+            <a:schemeClr val="accent1"/>
+          </a:fillRef>
+          <a:effectRef idx="2">
+            <a:schemeClr val="accent1"/>
+          </a:effectRef>
+          <a:fontRef idx="minor">
+            <a:schemeClr val="lt1"/>
+          </a:fontRef>
+        </p:style>
+        <p:txBody>
+          <a:bodyPr rtlCol="0" anchor="ctr"/>
+          <a:lstStyle/>
+        </p:txBody>
+      </p:sp>
+      <p:sp>
+        <p:nvSpPr>
+          <p:cNvPr id="5" name="TextBox 4"/>
+          <p:cNvSpPr txBox="1"/>
+          <p:nvPr/>
+        </p:nvSpPr>
+        <p:spPr>
+          <a:xfrm>
+            <a:off x="640080" y="1609344"/>
+            <a:ext cx="2743200" cy="457200"/>
+          </a:xfrm>
+          <a:prstGeom prst="rect">
+            <a:avLst/>
+          </a:prstGeom>
+          <a:noFill/>
+        </p:spPr>
+        <p:txBody>
+          <a:bodyPr wrap="square">
+            <a:spAutoFit/>
+          </a:bodyPr>
+          <a:lstStyle/>
+          <a:p>
+            <a:pPr algn="l"/>
+            <a:r>
+              <a:rPr lang="ja-JP" sz="1600" b="1" dirty="0">
+                <a:solidFill>
+                  <a:srgbClr val="1F4E79"/>
+                </a:solidFill>
+                <a:latin typeface="メイリオ"/>
+                <a:ea typeface="メイリオ"/>
+                <a:cs typeface="メイリオ"/>
+              </a:rPr>
+              <a:t>① 個別最適な学び</a:t>
+            </a:r>
+          </a:p>
+        </p:txBody>
+      </p:sp>
+      <p:sp>
+        <p:nvSpPr>
+          <p:cNvPr id="6" name="TextBox 5"/>
+          <p:cNvSpPr txBox="1"/>
+          <p:nvPr/>
+        </p:nvSpPr>
+        <p:spPr>
+          <a:xfrm>
+            <a:off x="3383280" y="1645920"/>
+            <a:ext cx="5120640" cy="822960"/>
+          </a:xfrm>
+          <a:prstGeom prst="rect">
+            <a:avLst/>
+          </a:prstGeom>
+          <a:noFill/>
+        </p:spPr>
+        <p:txBody>
+          <a:bodyPr wrap="square">
+            <a:spAutoFit/>
+          </a:bodyPr>
+          <a:lstStyle/>
+          <a:p>
+            <a:pPr algn="l"/>
+            <a:r>
+              <a:rPr lang="ja-JP" sz="1200" b="0" dirty="0">
+                <a:solidFill>
+                  <a:srgbClr val="000000"/>
+                </a:solidFill>
+                <a:latin typeface="メイリオ"/>
+                <a:ea typeface="メイリオ"/>
+                <a:cs typeface="メイリオ"/>
+              </a:rPr>
+              <a:t>習熟度・興味関心に応じた自分のペースの学習。</a:t>
+            </a:r>
+          </a:p>
+          <a:p>
+            <a:pPr algn="l"/>
+            <a:r>
+              <a:rPr lang="ja-JP" sz="1200" b="0" dirty="0">
+                <a:solidFill>
+                  <a:srgbClr val="000000"/>
+                </a:solidFill>
+                <a:latin typeface="メイリオ"/>
+                <a:ea typeface="メイリオ"/>
+                <a:cs typeface="メイリオ"/>
+              </a:rPr>
+              <a:t>試行錯誤を「自分のもの」にできる環境。</a:t>
+            </a:r>
+          </a:p>
+        </p:txBody>
+      </p:sp>
+      <p:sp>
+        <p:nvSpPr>
+          <p:cNvPr id="7" name="Rectangle 6"/>
+          <p:cNvSpPr/>
+          <p:nvPr/>
+        </p:nvSpPr>
+        <p:spPr>
+          <a:xfrm>
+            <a:off x="457200" y="2651760"/>
+            <a:ext cx="8229600" cy="960120"/>
+          </a:xfrm>
+          <a:prstGeom prst="rect">
+            <a:avLst/>
+          </a:prstGeom>
+          <a:solidFill>
+            <a:srgbClr val="E8F1FA"/>
+          </a:solidFill>
+          <a:ln w="19050">
+            <a:solidFill>
+              <a:srgbClr val="5B9BD5"/>
+            </a:solidFill>
+          </a:ln>
+        </p:spPr>
+        <p:style>
+          <a:lnRef idx="1">
+            <a:schemeClr val="accent1"/>
+          </a:lnRef>
+          <a:fillRef idx="3">
+            <a:schemeClr val="accent1"/>
+          </a:fillRef>
+          <a:effectRef idx="2">
+            <a:schemeClr val="accent1"/>
+          </a:effectRef>
+          <a:fontRef idx="minor">
+            <a:schemeClr val="lt1"/>
+          </a:fontRef>
+        </p:style>
+        <p:txBody>
+          <a:bodyPr rtlCol="0" anchor="ctr"/>
+          <a:lstStyle/>
+        </p:txBody>
+      </p:sp>
+      <p:sp>
+        <p:nvSpPr>
+          <p:cNvPr id="8" name="TextBox 7"/>
+          <p:cNvSpPr txBox="1"/>
+          <p:nvPr/>
+        </p:nvSpPr>
+        <p:spPr>
+          <a:xfrm>
+            <a:off x="640080" y="2706624"/>
+            <a:ext cx="2743200" cy="457200"/>
+          </a:xfrm>
+          <a:prstGeom prst="rect">
+            <a:avLst/>
+          </a:prstGeom>
+          <a:noFill/>
+        </p:spPr>
+        <p:txBody>
+          <a:bodyPr wrap="square">
+            <a:spAutoFit/>
+          </a:bodyPr>
+          <a:lstStyle/>
+          <a:p>
+            <a:pPr algn="l"/>
+            <a:r>
+              <a:rPr lang="ja-JP" sz="1600" b="1" dirty="0">
+                <a:solidFill>
+                  <a:srgbClr val="1F4E79"/>
+                </a:solidFill>
+                <a:latin typeface="メイリオ"/>
+                <a:ea typeface="メイリオ"/>
+                <a:cs typeface="メイリオ"/>
+              </a:rPr>
+              <a:t>② 協働的な学び</a:t>
+            </a:r>
+          </a:p>
+        </p:txBody>
+      </p:sp>
+      <p:sp>
+        <p:nvSpPr>
+          <p:cNvPr id="9" name="TextBox 8"/>
+          <p:cNvSpPr txBox="1"/>
+          <p:nvPr/>
+        </p:nvSpPr>
+        <p:spPr>
+          <a:xfrm>
+            <a:off x="3383280" y="2743200"/>
+            <a:ext cx="5120640" cy="822960"/>
+          </a:xfrm>
+          <a:prstGeom prst="rect">
+            <a:avLst/>
+          </a:prstGeom>
+          <a:noFill/>
+        </p:spPr>
+        <p:txBody>
+          <a:bodyPr wrap="square">
+            <a:spAutoFit/>
+          </a:bodyPr>
+          <a:lstStyle/>
+          <a:p>
+            <a:pPr algn="l"/>
+            <a:r>
+              <a:rPr lang="ja-JP" sz="1200" b="0" dirty="0">
+                <a:solidFill>
+                  <a:srgbClr val="000000"/>
+                </a:solidFill>
+                <a:latin typeface="メイリオ"/>
+                <a:ea typeface="メイリオ"/>
+                <a:cs typeface="メイリオ"/>
+              </a:rPr>
+              <a:t>考えのリアルタイム共有・比較。</a:t>
+            </a:r>
+          </a:p>
+          <a:p>
+            <a:pPr algn="l"/>
+            <a:r>
+              <a:rPr lang="ja-JP" sz="1200" b="0" dirty="0">
+                <a:solidFill>
+                  <a:srgbClr val="000000"/>
+                </a:solidFill>
+                <a:latin typeface="メイリオ"/>
+                <a:ea typeface="メイリオ"/>
+                <a:cs typeface="メイリオ"/>
+              </a:rPr>
+              <a:t>友達の見方を即座に取り入れて自分の学びを更新。</a:t>
+            </a:r>
+          </a:p>
+        </p:txBody>
+      </p:sp>
+      <p:sp>
+        <p:nvSpPr>
+          <p:cNvPr id="10" name="Rectangle 9"/>
+          <p:cNvSpPr/>
+          <p:nvPr/>
+        </p:nvSpPr>
+        <p:spPr>
+          <a:xfrm>
+            <a:off x="457200" y="3749039"/>
+            <a:ext cx="8229600" cy="960120"/>
+          </a:xfrm>
+          <a:prstGeom prst="rect">
+            <a:avLst/>
+          </a:prstGeom>
+          <a:solidFill>
+            <a:srgbClr val="E8F1FA"/>
+          </a:solidFill>
+          <a:ln w="19050">
+            <a:solidFill>
+              <a:srgbClr val="5B9BD5"/>
+            </a:solidFill>
+          </a:ln>
+        </p:spPr>
+        <p:style>
+          <a:lnRef idx="1">
+            <a:schemeClr val="accent1"/>
+          </a:lnRef>
+          <a:fillRef idx="3">
+            <a:schemeClr val="accent1"/>
+          </a:fillRef>
+          <a:effectRef idx="2">
+            <a:schemeClr val="accent1"/>
+          </a:effectRef>
+          <a:fontRef idx="minor">
+            <a:schemeClr val="lt1"/>
+          </a:fontRef>
+        </p:style>
+        <p:txBody>
+          <a:bodyPr rtlCol="0" anchor="ctr"/>
+          <a:lstStyle/>
+        </p:txBody>
+      </p:sp>
+      <p:sp>
+        <p:nvSpPr>
+          <p:cNvPr id="11" name="TextBox 10"/>
+          <p:cNvSpPr txBox="1"/>
+          <p:nvPr/>
+        </p:nvSpPr>
+        <p:spPr>
+          <a:xfrm>
+            <a:off x="640080" y="3803903"/>
+            <a:ext cx="2743200" cy="457200"/>
+          </a:xfrm>
+          <a:prstGeom prst="rect">
+            <a:avLst/>
+          </a:prstGeom>
+          <a:noFill/>
+        </p:spPr>
+        <p:txBody>
+          <a:bodyPr wrap="square">
+            <a:spAutoFit/>
+          </a:bodyPr>
+          <a:lstStyle/>
+          <a:p>
+            <a:pPr algn="l"/>
+            <a:r>
+              <a:rPr lang="ja-JP" sz="1600" b="1" dirty="0">
+                <a:solidFill>
+                  <a:srgbClr val="1F4E79"/>
+                </a:solidFill>
+                <a:latin typeface="メイリオ"/>
+                <a:ea typeface="メイリオ"/>
+                <a:cs typeface="メイリオ"/>
+              </a:rPr>
+              <a:t>③ 教師の見取り</a:t>
+            </a:r>
+          </a:p>
+        </p:txBody>
+      </p:sp>
+      <p:sp>
+        <p:nvSpPr>
+          <p:cNvPr id="12" name="TextBox 11"/>
+          <p:cNvSpPr txBox="1"/>
+          <p:nvPr/>
+        </p:nvSpPr>
+        <p:spPr>
+          <a:xfrm>
+            <a:off x="3383280" y="3840479"/>
+            <a:ext cx="5120640" cy="822960"/>
+          </a:xfrm>
+          <a:prstGeom prst="rect">
+            <a:avLst/>
+          </a:prstGeom>
+          <a:noFill/>
+        </p:spPr>
+        <p:txBody>
+          <a:bodyPr wrap="square">
+            <a:spAutoFit/>
+          </a:bodyPr>
+          <a:lstStyle/>
+          <a:p>
+            <a:pPr algn="l"/>
+            <a:r>
+              <a:rPr lang="ja-JP" sz="1200" b="0" dirty="0">
+                <a:solidFill>
+                  <a:srgbClr val="000000"/>
+                </a:solidFill>
+                <a:latin typeface="メイリオ"/>
+                <a:ea typeface="メイリオ"/>
+                <a:cs typeface="メイリオ"/>
+              </a:rPr>
+              <a:t>思考過程の可視化（手元・画面の記録）。</a:t>
+            </a:r>
+          </a:p>
+          <a:p>
+            <a:pPr algn="l"/>
+            <a:r>
+              <a:rPr lang="ja-JP" sz="1200" b="0" dirty="0">
+                <a:solidFill>
+                  <a:srgbClr val="000000"/>
+                </a:solidFill>
+                <a:latin typeface="メイリオ"/>
+                <a:ea typeface="メイリオ"/>
+                <a:cs typeface="メイリオ"/>
+              </a:rPr>
+              <a:t>つまずきや到達状況の把握と、的確な手立てへ。</a:t>
+            </a:r>
+          </a:p>
+        </p:txBody>
+      </p:sp>
+    </p:spTree>
+  </p:cSld>
+  <p:clrMapOvr>
+    <a:masterClrMapping/>
+  </p:clrMapOvr>
+</p:sld>
+</file>
+
+<file path=ppt/slides/slide17.xml><?xml version="1.0" encoding="utf-8"?>
 <p:sld xmlns:a="http://schemas.openxmlformats.org/drawingml/2006/main" xmlns:r="http://schemas.openxmlformats.org/officeDocument/2006/relationships" xmlns:p="http://schemas.openxmlformats.org/presentationml/2006/main">
   <p:cSld>
     <p:spTree>
@@ -13338,6 +13972,62 @@
                 <a:cs typeface="メイリオ"/>
               </a:rPr>
               <a:t>写真</a:t>
+            </a:r>
+          </a:p>
+        </p:txBody>
+      </p:sp>
+      <p:sp>
+        <p:nvSpPr>
+          <p:cNvPr id="9" name="正方形/長方形 8">
+            <a:extLst>
+              <a:ext uri="{FF2B5EF4-FFF2-40B4-BE49-F238E27FC236}">
+                <a16:creationId xmlns:a16="http://schemas.microsoft.com/office/drawing/2014/main" id="{77876903-AD43-5597-093C-B3A30EBDBD14}"/>
+              </a:ext>
+            </a:extLst>
+          </p:cNvPr>
+          <p:cNvSpPr/>
+          <p:nvPr/>
+        </p:nvSpPr>
+        <p:spPr bwMode="white">
+          <a:xfrm>
+            <a:off x="493776" y="4343400"/>
+            <a:ext cx="8156448" cy="685800"/>
+          </a:xfrm>
+          <a:prstGeom prst="rect">
+            <a:avLst/>
+          </a:prstGeom>
+          <a:solidFill>
+            <a:schemeClr val="bg1"/>
+          </a:solidFill>
+          <a:ln>
+            <a:noFill/>
+          </a:ln>
+        </p:spPr>
+        <p:txBody>
+          <a:bodyPr wrap="square">
+            <a:spAutoFit/>
+          </a:bodyPr>
+          <a:lstStyle/>
+          <a:p>
+            <a:pPr algn="l"/>
+            <a:r>
+              <a:rPr lang="ja-JP" sz="1800" b="1" dirty="0">
+                <a:latin typeface="メイリオ"/>
+                <a:ea typeface="メイリオ"/>
+                <a:cs typeface="メイリオ"/>
+              </a:rPr>
+              <a:t>5-1　外国語（三宅 真行）</a:t>
+            </a:r>
+          </a:p>
+          <a:p>
+            <a:pPr algn="l"/>
+            <a:r>
+              <a:rPr lang="ja-JP" sz="1400" b="0" dirty="0">
+                <a:latin typeface="メイリオ"/>
+                <a:ea typeface="メイリオ"/>
+                <a:cs typeface="メイリオ"/>
+              </a:rPr>
+              <a:t>Unit 2「When is your birthday?」</a:t>
             </a:r>
           </a:p>
         </p:txBody>

</xml_diff>